<commit_message>
Add network reset failure slide
Co-authored-by: 36613453226Wallen <36613453226Wallen@users.noreply.github.com>
</commit_message>
<xml_diff>
--- a/Files/PPT-Producer/Git使用过程短问题.pptx
+++ b/Files/PPT-Producer/Git使用过程短问题.pptx
@@ -11,6 +11,7 @@
     <p:sldId id="259" r:id="rId10"/>
     <p:sldId id="260" r:id="rId11"/>
     <p:sldId id="261" r:id="rId12"/>
+    <p:sldId id="262" r:id="rId13"/>
   </p:sldIdLst>
   <p:sldSz cx="12191695" cy="6858000" type="screen4x3"/>
   <p:notesSz cx="6858000" cy="9144000"/>
@@ -9755,6 +9756,230 @@
                 <a:latin typeface="Microsoft YaHei"/>
               </a:rPr>
               <a:t>06</a:t>
+            </a:r>
+          </a:p>
+        </p:txBody>
+      </p:sp>
+    </p:spTree>
+  </p:cSld>
+  <p:clrMapOvr>
+    <a:masterClrMapping/>
+  </p:clrMapOvr>
+</p:sld>
+</file>
+
+<file path=ppt/slides/slide7.xml><?xml version="1.0" encoding="utf-8"?>
+<p:sld xmlns:a="http://schemas.openxmlformats.org/drawingml/2006/main" xmlns:p="http://schemas.openxmlformats.org/presentationml/2006/main" xmlns:r="http://schemas.openxmlformats.org/officeDocument/2006/relationships">
+  <p:cSld>
+    <p:bg>
+      <p:bgPr>
+        <a:solidFill>
+          <a:srgbClr val="F5F7FB"/>
+        </a:solidFill>
+        <a:effectLst/>
+      </p:bgPr>
+    </p:bg>
+    <p:spTree>
+      <p:nvGrpSpPr>
+        <p:cNvPr id="1" name=""/>
+        <p:cNvGrpSpPr/>
+        <p:nvPr/>
+      </p:nvGrpSpPr>
+      <p:grpSpPr/>
+      <p:sp>
+        <p:nvSpPr>
+          <p:cNvPr id="2" name="TextBox 1"/>
+          <p:cNvSpPr txBox="1"/>
+          <p:nvPr/>
+        </p:nvSpPr>
+        <p:spPr>
+          <a:xfrm>
+            <a:off x="621792" y="256032"/>
+            <a:ext cx="7132320" cy="475488"/>
+          </a:xfrm>
+          <a:prstGeom prst="rect">
+            <a:avLst/>
+          </a:prstGeom>
+          <a:noFill/>
+        </p:spPr>
+        <p:txBody>
+          <a:bodyPr wrap="square" anchor="ctr" lIns="36576" rIns="36576" tIns="18288" bIns="18288">
+            <a:spAutoFit/>
+          </a:bodyPr>
+          <a:lstStyle/>
+          <a:p>
+            <a:pPr algn="l"/>
+            <a:r>
+              <a:rPr sz="2600" b="1">
+                <a:solidFill>
+                  <a:srgbClr val="24324A"/>
+                </a:solidFill>
+                <a:latin typeface="Microsoft YaHei"/>
+              </a:rPr>
+              <a:t>Windows 网络重置：操作记录</a:t>
+            </a:r>
+          </a:p>
+        </p:txBody>
+      </p:sp>
+      <p:sp>
+        <p:nvSpPr>
+          <p:cNvPr id="3" name="TextBox 2"/>
+          <p:cNvSpPr txBox="1"/>
+          <p:nvPr/>
+        </p:nvSpPr>
+        <p:spPr>
+          <a:xfrm>
+            <a:off x="640080" y="713232"/>
+            <a:ext cx="6217920" cy="274320"/>
+          </a:xfrm>
+          <a:prstGeom prst="rect">
+            <a:avLst/>
+          </a:prstGeom>
+          <a:noFill/>
+        </p:spPr>
+        <p:txBody>
+          <a:bodyPr wrap="square" anchor="ctr" lIns="36576" rIns="36576" tIns="18288" bIns="18288">
+            <a:spAutoFit/>
+          </a:bodyPr>
+          <a:lstStyle/>
+          <a:p>
+            <a:pPr algn="l"/>
+            <a:r>
+              <a:rPr sz="1100" b="0">
+                <a:solidFill>
+                  <a:srgbClr val="6B778C"/>
+                </a:solidFill>
+                <a:latin typeface="Microsoft YaHei"/>
+              </a:rPr>
+              <a:t>按照网络重置路径进行查找和操作</a:t>
+            </a:r>
+          </a:p>
+        </p:txBody>
+      </p:sp>
+      <p:pic>
+        <p:nvPicPr>
+          <p:cNvPr id="4" name="Picture 3" descr="network-reset-phone.png"/>
+          <p:cNvPicPr>
+            <a:picLocks noChangeAspect="1"/>
+          </p:cNvPicPr>
+          <p:nvPr/>
+        </p:nvPicPr>
+        <p:blipFill>
+          <a:blip r:embed="rId2"/>
+          <a:stretch>
+            <a:fillRect/>
+          </a:stretch>
+        </p:blipFill>
+        <p:spPr>
+          <a:xfrm>
+            <a:off x="676656" y="1097280"/>
+            <a:ext cx="2743200" cy="5084064"/>
+          </a:xfrm>
+          <a:prstGeom prst="rect">
+            <a:avLst/>
+          </a:prstGeom>
+        </p:spPr>
+      </p:pic>
+      <p:pic>
+        <p:nvPicPr>
+          <p:cNvPr id="5" name="Picture 4" descr="network-reset-instruction.png"/>
+          <p:cNvPicPr>
+            <a:picLocks noChangeAspect="1"/>
+          </p:cNvPicPr>
+          <p:nvPr/>
+        </p:nvPicPr>
+        <p:blipFill>
+          <a:blip r:embed="rId3"/>
+          <a:stretch>
+            <a:fillRect/>
+          </a:stretch>
+        </p:blipFill>
+        <p:spPr>
+          <a:xfrm>
+            <a:off x="3794760" y="1225296"/>
+            <a:ext cx="7726679" cy="4343400"/>
+          </a:xfrm>
+          <a:prstGeom prst="rect">
+            <a:avLst/>
+          </a:prstGeom>
+        </p:spPr>
+      </p:pic>
+      <p:sp>
+        <p:nvSpPr>
+          <p:cNvPr id="6" name="Rounded Rectangle 5"/>
+          <p:cNvSpPr/>
+          <p:nvPr/>
+        </p:nvSpPr>
+        <p:spPr>
+          <a:xfrm>
+            <a:off x="5943600" y="5751576"/>
+            <a:ext cx="3456432" cy="566928"/>
+          </a:xfrm>
+          <a:prstGeom prst="roundRect">
+            <a:avLst/>
+          </a:prstGeom>
+          <a:solidFill>
+            <a:srgbClr val="FDECEC"/>
+          </a:solidFill>
+          <a:ln w="19050">
+            <a:solidFill>
+              <a:srgbClr val="D94A4A"/>
+            </a:solidFill>
+          </a:ln>
+        </p:spPr>
+        <p:style>
+          <a:lnRef idx="1">
+            <a:schemeClr val="accent1"/>
+          </a:lnRef>
+          <a:fillRef idx="3">
+            <a:schemeClr val="accent1"/>
+          </a:fillRef>
+          <a:effectRef idx="2">
+            <a:schemeClr val="accent1"/>
+          </a:effectRef>
+          <a:fontRef idx="minor">
+            <a:schemeClr val="lt1"/>
+          </a:fontRef>
+        </p:style>
+        <p:txBody>
+          <a:bodyPr rtlCol="0" anchor="ctr"/>
+          <a:lstStyle/>
+          <a:p>
+            <a:pPr algn="ctr"/>
+          </a:p>
+        </p:txBody>
+      </p:sp>
+      <p:sp>
+        <p:nvSpPr>
+          <p:cNvPr id="7" name="TextBox 6"/>
+          <p:cNvSpPr txBox="1"/>
+          <p:nvPr/>
+        </p:nvSpPr>
+        <p:spPr>
+          <a:xfrm>
+            <a:off x="5943600" y="5751576"/>
+            <a:ext cx="3456432" cy="566928"/>
+          </a:xfrm>
+          <a:prstGeom prst="rect">
+            <a:avLst/>
+          </a:prstGeom>
+          <a:noFill/>
+        </p:spPr>
+        <p:txBody>
+          <a:bodyPr wrap="square" anchor="ctr" lIns="36576" rIns="36576" tIns="18288" bIns="18288">
+            <a:spAutoFit/>
+          </a:bodyPr>
+          <a:lstStyle/>
+          <a:p>
+            <a:pPr algn="ctr"/>
+            <a:r>
+              <a:rPr sz="2000" b="1">
+                <a:solidFill>
+                  <a:srgbClr val="D94A4A"/>
+                </a:solidFill>
+                <a:latin typeface="Microsoft YaHei"/>
+              </a:rPr>
+              <a:t>没有操作成功</a:t>
             </a:r>
           </a:p>
         </p:txBody>

</xml_diff>